<commit_message>
Use template author names and neutral affiliation in report and slides
</commit_message>
<xml_diff>
--- a/results/slides/SiLU_class_presentation.pptx
+++ b/results/slides/SiLU_class_presentation.pptx
@@ -1041,7 +1041,7 @@
           <a:p>
             <a:r>
               <a:rPr lang="en-US" dirty="0"/>
-              <a:t>The professor's objection: hand-typing '1 cycle' into gem5. Now run_gem5.py computes latency from the Quartus delay and the clock. Multi-cycle: ceil(d/T). Pipelined: smallest N with d/N + 0.3 ns &lt;= T (0.3 ns is an assumption).</a:t>
+              <a:t>A hand-typed '1 cycle' in gem5 would disconnect synthesis from simulation. Now run_gem5.py computes latency from the Quartus delay and the clock. Multi-cycle: ceil(d/T). Pipelined: smallest N with d/N + 0.3 ns &lt;= T (0.3 ns is an assumption).</a:t>
             </a:r>
             <a:endParaRPr lang="en-US" dirty="0"/>
           </a:p>
@@ -2111,8 +2111,8 @@
         </p:nvSpPr>
         <p:spPr>
           <a:xfrm>
-            <a:off x="640080" y="4114800"/>
-            <a:ext cx="7863840" cy="365760"/>
+            <a:off x="640080" y="3931920"/>
+            <a:ext cx="7863840" cy="640080"/>
           </a:xfrm>
           <a:prstGeom prst="rect">
             <a:avLst/>
@@ -2136,7 +2136,24 @@
                 <a:ea typeface="Calibri" pitchFamily="34" charset="-122"/>
                 <a:cs typeface="Calibri" pitchFamily="34" charset="-120"/>
               </a:rPr>
-              <a:t>Ayush Krishna · B.Tech Electronics &amp; VLSI, VIT Vellore · BAEVD202 Computer Architecture</a:t>
+              <a:t>First Author · Second Author · Third Author · Fourth Author · Fifth Author</a:t>
+            </a:r>
+            <a:endParaRPr lang="en-US" sz="1400" dirty="0"/>
+          </a:p>
+          <a:p>
+            <a:pPr indent="0" marL="0">
+              <a:buNone/>
+            </a:pPr>
+            <a:r>
+              <a:rPr lang="en-US" sz="1400" dirty="0">
+                <a:solidFill>
+                  <a:srgbClr val="BFD4F2"/>
+                </a:solidFill>
+                <a:latin typeface="Calibri" pitchFamily="34" charset="0"/>
+                <a:ea typeface="Calibri" pitchFamily="34" charset="-122"/>
+                <a:cs typeface="Calibri" pitchFamily="34" charset="-120"/>
+              </a:rPr>
+              <a:t>Department of Electronics Engineering, University Name</a:t>
             </a:r>
             <a:endParaRPr lang="en-US" sz="1400" dirty="0"/>
           </a:p>
@@ -4482,7 +4499,7 @@
                 <a:ea typeface="Calibri" pitchFamily="34" charset="-122"/>
                 <a:cs typeface="Calibri" pitchFamily="34" charset="-120"/>
               </a:rPr>
-              <a:t>github.com/normie2099/SiLU-Architecture</a:t>
+              <a:t>Project repository: &lt;link&gt;</a:t>
             </a:r>
             <a:endParaRPr lang="en-US" sz="1200" dirty="0"/>
           </a:p>

</xml_diff>